<commit_message>
Regenerate PPTX presentation with updated team and logos
- Add IUT Creteil-Vitry and LISSI logos to title slide
- Add PO M. CHIBANI and NEXUS AI Innovation Lab
- Update date to February 2026
- Fix multi-language status to 100%
- Fix 14 Docker services (was 15)
- Add GitHub link in annexes
- Fix python-pptx RGBColor import compatibility
</commit_message>
<xml_diff>
--- a/presentations/IAM_Gateway_UPEC.pptx
+++ b/presentations/IAM_Gateway_UPEC.pptx
@@ -3170,17 +3170,41 @@
         </p:blipFill>
         <p:spPr>
           <a:xfrm>
-            <a:off x="2743200" y="457200"/>
-            <a:ext cx="3657600" cy="1854044"/>
+            <a:off x="457200" y="274320"/>
+            <a:ext cx="2164679" cy="1097280"/>
           </a:xfrm>
           <a:prstGeom prst="rect">
             <a:avLst/>
           </a:prstGeom>
         </p:spPr>
       </p:pic>
-      <p:sp>
-        <p:nvSpPr>
-          <p:cNvPr id="4" name="TextBox 3"/>
+      <p:pic>
+        <p:nvPicPr>
+          <p:cNvPr id="4" name="Picture 3" descr="Lissi-cmjn.png"/>
+          <p:cNvPicPr>
+            <a:picLocks noChangeAspect="1"/>
+          </p:cNvPicPr>
+          <p:nvPr/>
+        </p:nvPicPr>
+        <p:blipFill>
+          <a:blip r:embed="rId3"/>
+          <a:stretch>
+            <a:fillRect/>
+          </a:stretch>
+        </p:blipFill>
+        <p:spPr>
+          <a:xfrm>
+            <a:off x="5486400" y="274320"/>
+            <a:ext cx="3338481" cy="914400"/>
+          </a:xfrm>
+          <a:prstGeom prst="rect">
+            <a:avLst/>
+          </a:prstGeom>
+        </p:spPr>
+      </p:pic>
+      <p:sp>
+        <p:nvSpPr>
+          <p:cNvPr id="5" name="TextBox 4"/>
           <p:cNvSpPr txBox="1"/>
           <p:nvPr/>
         </p:nvSpPr>
@@ -3215,7 +3239,7 @@
       </p:sp>
       <p:sp>
         <p:nvSpPr>
-          <p:cNvPr id="5" name="TextBox 4"/>
+          <p:cNvPr id="6" name="TextBox 5"/>
           <p:cNvSpPr txBox="1"/>
           <p:nvPr/>
         </p:nvSpPr>
@@ -3250,7 +3274,7 @@
       </p:sp>
       <p:sp>
         <p:nvSpPr>
-          <p:cNvPr id="6" name="TextBox 5"/>
+          <p:cNvPr id="7" name="TextBox 6"/>
           <p:cNvSpPr txBox="1"/>
           <p:nvPr/>
         </p:nvSpPr>
@@ -3278,14 +3302,14 @@
               </a:defRPr>
             </a:pPr>
             <a:r>
-              <a:t>Zhmuryk Andrii &amp; Aydin Ibrahim</a:t>
-            </a:r>
-          </a:p>
-        </p:txBody>
-      </p:sp>
-      <p:sp>
-        <p:nvSpPr>
-          <p:cNvPr id="7" name="TextBox 6"/>
+              <a:t>Equipe MOE: Zhmuryk Andrii &amp; Aydin Ibrahim</a:t>
+            </a:r>
+          </a:p>
+        </p:txBody>
+      </p:sp>
+      <p:sp>
+        <p:nvSpPr>
+          <p:cNvPr id="8" name="TextBox 7"/>
           <p:cNvSpPr txBox="1"/>
           <p:nvPr/>
         </p:nvSpPr>
@@ -3314,7 +3338,7 @@
               </a:defRPr>
             </a:pPr>
             <a:r>
-              <a:t>BUT Informatique 3eme annee</a:t>
+              <a:t>Product Owner &amp; Architecture: M. CHIBANI</a:t>
             </a:r>
           </a:p>
           <a:p>
@@ -3326,7 +3350,7 @@
               </a:defRPr>
             </a:pPr>
             <a:r>
-              <a:t>Universite Paris-Est Creteil</a:t>
+              <a:t>BUT Informatique 3eme annee - UPEC</a:t>
             </a:r>
           </a:p>
           <a:p>
@@ -3338,7 +3362,7 @@
               </a:defRPr>
             </a:pPr>
             <a:r>
-              <a:t>Departement Informatique</a:t>
+              <a:t>IUT Creteil-Vitry | Laboratoire LISSI</a:t>
             </a:r>
           </a:p>
           <a:p>
@@ -3350,7 +3374,7 @@
               </a:defRPr>
             </a:pPr>
             <a:r>
-              <a:t>Janvier 2026</a:t>
+              <a:t>NEXUS AI Innovation Lab - Fevrier 2026</a:t>
             </a:r>
           </a:p>
         </p:txBody>
@@ -4859,30 +4883,6 @@
           </a:p>
         </p:txBody>
       </p:sp>
-      <p:pic>
-        <p:nvPicPr>
-          <p:cNvPr id="6" name="Picture 5" descr="ldap-groups.png"/>
-          <p:cNvPicPr>
-            <a:picLocks noChangeAspect="1"/>
-          </p:cNvPicPr>
-          <p:nvPr/>
-        </p:nvPicPr>
-        <p:blipFill>
-          <a:blip r:embed="rId2"/>
-          <a:stretch>
-            <a:fillRect/>
-          </a:stretch>
-        </p:blipFill>
-        <p:spPr>
-          <a:xfrm>
-            <a:off x="4754880" y="1097280"/>
-            <a:ext cx="4114800" cy="1975282"/>
-          </a:xfrm>
-          <a:prstGeom prst="rect">
-            <a:avLst/>
-          </a:prstGeom>
-        </p:spPr>
-      </p:pic>
     </p:spTree>
   </p:cSld>
   <p:clrMapOvr>
@@ -5181,30 +5181,6 @@
           </a:p>
         </p:txBody>
       </p:sp>
-      <p:pic>
-        <p:nvPicPr>
-          <p:cNvPr id="6" name="Picture 5" descr="comparaison-live.png"/>
-          <p:cNvPicPr>
-            <a:picLocks noChangeAspect="1"/>
-          </p:cNvPicPr>
-          <p:nvPr/>
-        </p:nvPicPr>
-        <p:blipFill>
-          <a:blip r:embed="rId2"/>
-          <a:stretch>
-            <a:fillRect/>
-          </a:stretch>
-        </p:blipFill>
-        <p:spPr>
-          <a:xfrm>
-            <a:off x="4754880" y="1097280"/>
-            <a:ext cx="4114800" cy="1975282"/>
-          </a:xfrm>
-          <a:prstGeom prst="rect">
-            <a:avLst/>
-          </a:prstGeom>
-        </p:spPr>
-      </p:pic>
     </p:spTree>
   </p:cSld>
   <p:clrMapOvr>
@@ -6109,7 +6085,7 @@
                         </a:defRPr>
                       </a:pPr>
                       <a:r>
-                        <a:t>10%</a:t>
+                        <a:t>100%</a:t>
                       </a:r>
                     </a:p>
                   </a:txBody>
@@ -6132,7 +6108,7 @@
                         </a:defRPr>
                       </a:pPr>
                       <a:r>
-                        <a:t>i18n React</a:t>
+                        <a:t>FR, EN, UK (i18next)</a:t>
                       </a:r>
                     </a:p>
                   </a:txBody>
@@ -9096,7 +9072,7 @@
               </a:defRPr>
             </a:pPr>
             <a:r>
-              <a:t>- 15 services Docker</a:t>
+              <a:t>- 14 services Docker orchestres</a:t>
             </a:r>
           </a:p>
           <a:p>
@@ -9120,7 +9096,7 @@
               </a:defRPr>
             </a:pPr>
             <a:r>
-              <a:t>- 6 connecteurs systemes</a:t>
+              <a:t>- 6 connecteurs (LDAP, SQL, Odoo, MidPoint, Keycloak, CSV)</a:t>
             </a:r>
           </a:p>
           <a:p>
@@ -9132,7 +9108,19 @@
               </a:defRPr>
             </a:pPr>
             <a:r>
-              <a:t>- 14 pages Frontend</a:t>
+              <a:t>- 15 pages Frontend</a:t>
+            </a:r>
+          </a:p>
+          <a:p>
+            <a:pPr lvl="1">
+              <a:defRPr sz="1600">
+                <a:solidFill>
+                  <a:srgbClr val="FFFFFF"/>
+                </a:solidFill>
+              </a:defRPr>
+            </a:pPr>
+            <a:r>
+              <a:t>- 3 langues (FR, EN, UK)</a:t>
             </a:r>
           </a:p>
         </p:txBody>
@@ -9406,7 +9394,7 @@
               </a:defRPr>
             </a:pPr>
             <a:r>
-              <a:t>- Code source: [Repository Git]</a:t>
+              <a:t>- GitHub: github.com/NEXUS-AI-Innovation-lab/IAM-Gateway</a:t>
             </a:r>
           </a:p>
           <a:p>
@@ -9418,7 +9406,7 @@
               </a:defRPr>
             </a:pPr>
             <a:r>
-              <a:t>- Documentation: /docs/</a:t>
+              <a:t>- Documentation: docs/GUIDE_DEVELOPPEUR.md</a:t>
             </a:r>
           </a:p>
           <a:p>
@@ -9538,7 +9526,7 @@
               </a:defRPr>
             </a:pPr>
             <a:r>
-              <a:t>- Zhmuryk Andrii</a:t>
+              <a:t>- Zhmuryk Andrii: andrijzmurik@gmail.com</a:t>
             </a:r>
           </a:p>
           <a:p>
@@ -9583,19 +9571,31 @@
               </a:defRPr>
             </a:pPr>
             <a:r>
-              <a:t>- Professeur encadrant</a:t>
-            </a:r>
-          </a:p>
-          <a:p>
-            <a:pPr>
-              <a:defRPr sz="1600">
-                <a:solidFill>
-                  <a:srgbClr val="FFFFFF"/>
-                </a:solidFill>
-              </a:defRPr>
-            </a:pPr>
-            <a:r>
-              <a:t>- Departement Informatique UPEC</a:t>
+              <a:t>- PO &amp; Architecture: M. CHIBANI</a:t>
+            </a:r>
+          </a:p>
+          <a:p>
+            <a:pPr>
+              <a:defRPr sz="1600">
+                <a:solidFill>
+                  <a:srgbClr val="FFFFFF"/>
+                </a:solidFill>
+              </a:defRPr>
+            </a:pPr>
+            <a:r>
+              <a:t>- IUT Creteil-Vitry - Dept. Informatique</a:t>
+            </a:r>
+          </a:p>
+          <a:p>
+            <a:pPr>
+              <a:defRPr sz="1600">
+                <a:solidFill>
+                  <a:srgbClr val="FFFFFF"/>
+                </a:solidFill>
+              </a:defRPr>
+            </a:pPr>
+            <a:r>
+              <a:t>- Laboratoire LISSI - UPEC</a:t>
             </a:r>
           </a:p>
           <a:p>
@@ -11506,7 +11506,7 @@
               </a:defRPr>
             </a:pPr>
             <a:r>
-              <a:t>Architecture Technique - 15 Services Docker</a:t>
+              <a:t>Architecture Technique - 14 Services Docker</a:t>
             </a:r>
           </a:p>
         </p:txBody>
@@ -12833,30 +12833,6 @@
           </a:p>
         </p:txBody>
       </p:sp>
-      <p:pic>
-        <p:nvPicPr>
-          <p:cNvPr id="6" name="Picture 5" descr="dashboard.png"/>
-          <p:cNvPicPr>
-            <a:picLocks noChangeAspect="1"/>
-          </p:cNvPicPr>
-          <p:nvPr/>
-        </p:nvPicPr>
-        <p:blipFill>
-          <a:blip r:embed="rId2"/>
-          <a:stretch>
-            <a:fillRect/>
-          </a:stretch>
-        </p:blipFill>
-        <p:spPr>
-          <a:xfrm>
-            <a:off x="4754880" y="1097280"/>
-            <a:ext cx="4114800" cy="1975282"/>
-          </a:xfrm>
-          <a:prstGeom prst="rect">
-            <a:avLst/>
-          </a:prstGeom>
-        </p:spPr>
-      </p:pic>
     </p:spTree>
   </p:cSld>
   <p:clrMapOvr>

</xml_diff>